<commit_message>
ultime modifiche alla presentazione
</commit_message>
<xml_diff>
--- a/AI-Recipe-Generator.pptx
+++ b/AI-Recipe-Generator.pptx
@@ -205,7 +205,7 @@
           <a:p>
             <a:fld id="{2CBC5FEC-EDC7-4C9C-B6E1-DE6875119B4C}" type="datetimeFigureOut">
               <a:rPr lang="it-IT" smtClean="0"/>
-              <a:t>21/07/2026</a:t>
+              <a:t>22/07/2026</a:t>
             </a:fld>
             <a:endParaRPr lang="it-IT"/>
           </a:p>
@@ -703,7 +703,7 @@
           <a:p>
             <a:fld id="{26FD1466-454B-4EB1-A92A-6F211C43132E}" type="datetimeFigureOut">
               <a:rPr lang="it-IT" smtClean="0"/>
-              <a:t>21/07/2026</a:t>
+              <a:t>22/07/2026</a:t>
             </a:fld>
             <a:endParaRPr lang="it-IT"/>
           </a:p>
@@ -901,7 +901,7 @@
           <a:p>
             <a:fld id="{26FD1466-454B-4EB1-A92A-6F211C43132E}" type="datetimeFigureOut">
               <a:rPr lang="it-IT" smtClean="0"/>
-              <a:t>21/07/2026</a:t>
+              <a:t>22/07/2026</a:t>
             </a:fld>
             <a:endParaRPr lang="it-IT"/>
           </a:p>
@@ -1109,7 +1109,7 @@
           <a:p>
             <a:fld id="{26FD1466-454B-4EB1-A92A-6F211C43132E}" type="datetimeFigureOut">
               <a:rPr lang="it-IT" smtClean="0"/>
-              <a:t>21/07/2026</a:t>
+              <a:t>22/07/2026</a:t>
             </a:fld>
             <a:endParaRPr lang="it-IT"/>
           </a:p>
@@ -1307,7 +1307,7 @@
           <a:p>
             <a:fld id="{26FD1466-454B-4EB1-A92A-6F211C43132E}" type="datetimeFigureOut">
               <a:rPr lang="it-IT" smtClean="0"/>
-              <a:t>21/07/2026</a:t>
+              <a:t>22/07/2026</a:t>
             </a:fld>
             <a:endParaRPr lang="it-IT"/>
           </a:p>
@@ -1582,7 +1582,7 @@
           <a:p>
             <a:fld id="{26FD1466-454B-4EB1-A92A-6F211C43132E}" type="datetimeFigureOut">
               <a:rPr lang="it-IT" smtClean="0"/>
-              <a:t>21/07/2026</a:t>
+              <a:t>22/07/2026</a:t>
             </a:fld>
             <a:endParaRPr lang="it-IT"/>
           </a:p>
@@ -1847,7 +1847,7 @@
           <a:p>
             <a:fld id="{26FD1466-454B-4EB1-A92A-6F211C43132E}" type="datetimeFigureOut">
               <a:rPr lang="it-IT" smtClean="0"/>
-              <a:t>21/07/2026</a:t>
+              <a:t>22/07/2026</a:t>
             </a:fld>
             <a:endParaRPr lang="it-IT"/>
           </a:p>
@@ -2259,7 +2259,7 @@
           <a:p>
             <a:fld id="{26FD1466-454B-4EB1-A92A-6F211C43132E}" type="datetimeFigureOut">
               <a:rPr lang="it-IT" smtClean="0"/>
-              <a:t>21/07/2026</a:t>
+              <a:t>22/07/2026</a:t>
             </a:fld>
             <a:endParaRPr lang="it-IT"/>
           </a:p>
@@ -2400,7 +2400,7 @@
           <a:p>
             <a:fld id="{26FD1466-454B-4EB1-A92A-6F211C43132E}" type="datetimeFigureOut">
               <a:rPr lang="it-IT" smtClean="0"/>
-              <a:t>21/07/2026</a:t>
+              <a:t>22/07/2026</a:t>
             </a:fld>
             <a:endParaRPr lang="it-IT"/>
           </a:p>
@@ -2513,7 +2513,7 @@
           <a:p>
             <a:fld id="{26FD1466-454B-4EB1-A92A-6F211C43132E}" type="datetimeFigureOut">
               <a:rPr lang="it-IT" smtClean="0"/>
-              <a:t>21/07/2026</a:t>
+              <a:t>22/07/2026</a:t>
             </a:fld>
             <a:endParaRPr lang="it-IT"/>
           </a:p>
@@ -2824,7 +2824,7 @@
           <a:p>
             <a:fld id="{26FD1466-454B-4EB1-A92A-6F211C43132E}" type="datetimeFigureOut">
               <a:rPr lang="it-IT" smtClean="0"/>
-              <a:t>21/07/2026</a:t>
+              <a:t>22/07/2026</a:t>
             </a:fld>
             <a:endParaRPr lang="it-IT"/>
           </a:p>
@@ -3112,7 +3112,7 @@
           <a:p>
             <a:fld id="{26FD1466-454B-4EB1-A92A-6F211C43132E}" type="datetimeFigureOut">
               <a:rPr lang="it-IT" smtClean="0"/>
-              <a:t>21/07/2026</a:t>
+              <a:t>22/07/2026</a:t>
             </a:fld>
             <a:endParaRPr lang="it-IT"/>
           </a:p>
@@ -3353,7 +3353,7 @@
           <a:p>
             <a:fld id="{26FD1466-454B-4EB1-A92A-6F211C43132E}" type="datetimeFigureOut">
               <a:rPr lang="it-IT" smtClean="0"/>
-              <a:t>21/07/2026</a:t>
+              <a:t>22/07/2026</a:t>
             </a:fld>
             <a:endParaRPr lang="it-IT"/>
           </a:p>
@@ -11149,10 +11149,13 @@
                   </a:rPr>
                   <a:t>embeddings</a:t>
                 </a:r>
-                <a:endParaRPr lang="it-IT" sz="2200" dirty="0">
-                  <a:latin typeface="Times New Roman" panose="02020603050405020304" pitchFamily="18" charset="0"/>
-                  <a:cs typeface="Times New Roman" panose="02020603050405020304" pitchFamily="18" charset="0"/>
-                </a:endParaRPr>
+                <a:r>
+                  <a:rPr lang="it-IT" sz="2200" dirty="0">
+                    <a:latin typeface="Times New Roman" panose="02020603050405020304" pitchFamily="18" charset="0"/>
+                    <a:cs typeface="Times New Roman" panose="02020603050405020304" pitchFamily="18" charset="0"/>
+                  </a:rPr>
+                  <a:t>.</a:t>
+                </a:r>
               </a:p>
               <a:p>
                 <a:pPr marL="0" indent="0">
@@ -11168,18 +11171,39 @@
                   <a:buNone/>
                 </a:pPr>
                 <a:r>
+                  <a:rPr lang="it-IT" sz="2200" dirty="0">
+                    <a:latin typeface="Times New Roman" panose="02020603050405020304" pitchFamily="18" charset="0"/>
+                    <a:cs typeface="Times New Roman" panose="02020603050405020304" pitchFamily="18" charset="0"/>
+                  </a:rPr>
+                  <a:t>La funzione </a:t>
+                </a:r>
+                <a:r>
                   <a:rPr lang="it-IT" sz="2200" dirty="0" err="1">
                     <a:latin typeface="Times New Roman" panose="02020603050405020304" pitchFamily="18" charset="0"/>
                     <a:cs typeface="Times New Roman" panose="02020603050405020304" pitchFamily="18" charset="0"/>
                   </a:rPr>
-                  <a:t>faiss.search</a:t>
+                  <a:t>search</a:t>
                 </a:r>
                 <a:r>
                   <a:rPr lang="it-IT" sz="2200" dirty="0">
                     <a:latin typeface="Times New Roman" panose="02020603050405020304" pitchFamily="18" charset="0"/>
                     <a:cs typeface="Times New Roman" panose="02020603050405020304" pitchFamily="18" charset="0"/>
                   </a:rPr>
-                  <a:t>() assegna ad ogni ricetta uno score di somiglianza tramite la cosine </a:t>
+                  <a:t> di </a:t>
+                </a:r>
+                <a:r>
+                  <a:rPr lang="it-IT" sz="2200" dirty="0" err="1">
+                    <a:latin typeface="Times New Roman" panose="02020603050405020304" pitchFamily="18" charset="0"/>
+                    <a:cs typeface="Times New Roman" panose="02020603050405020304" pitchFamily="18" charset="0"/>
+                  </a:rPr>
+                  <a:t>faiss</a:t>
+                </a:r>
+                <a:r>
+                  <a:rPr lang="it-IT" sz="2200" dirty="0">
+                    <a:latin typeface="Times New Roman" panose="02020603050405020304" pitchFamily="18" charset="0"/>
+                    <a:cs typeface="Times New Roman" panose="02020603050405020304" pitchFamily="18" charset="0"/>
+                  </a:rPr>
+                  <a:t> assegna ad ogni ricetta uno score di somiglianza tramite la cosine </a:t>
                 </a:r>
                 <a:r>
                   <a:rPr lang="it-IT" sz="2200" dirty="0" err="1">
@@ -11188,10 +11212,13 @@
                   </a:rPr>
                   <a:t>similarity</a:t>
                 </a:r>
-                <a:endParaRPr lang="it-IT" sz="2200" dirty="0">
-                  <a:latin typeface="Times New Roman" panose="02020603050405020304" pitchFamily="18" charset="0"/>
-                  <a:cs typeface="Times New Roman" panose="02020603050405020304" pitchFamily="18" charset="0"/>
-                </a:endParaRPr>
+                <a:r>
+                  <a:rPr lang="it-IT" sz="2200" dirty="0">
+                    <a:latin typeface="Times New Roman" panose="02020603050405020304" pitchFamily="18" charset="0"/>
+                    <a:cs typeface="Times New Roman" panose="02020603050405020304" pitchFamily="18" charset="0"/>
+                  </a:rPr>
+                  <a:t>.</a:t>
+                </a:r>
               </a:p>
               <a:p>
                 <a:pPr marL="0" indent="0">
@@ -11346,7 +11373,7 @@
                     <a:latin typeface="Times New Roman" panose="02020603050405020304" pitchFamily="18" charset="0"/>
                     <a:cs typeface="Times New Roman" panose="02020603050405020304" pitchFamily="18" charset="0"/>
                   </a:rPr>
-                  <a:t>Le ricette vengono ordinate in base allo score e restituite le  </a:t>
+                  <a:t>Le ricette vengono ordinate in base allo score e vengono restituite le </a:t>
                 </a:r>
                 <a:r>
                   <a:rPr lang="it-IT" sz="2200" dirty="0" err="1">
@@ -11355,10 +11382,13 @@
                   </a:rPr>
                   <a:t>top_k</a:t>
                 </a:r>
-                <a:endParaRPr lang="it-IT" sz="2200" dirty="0">
-                  <a:latin typeface="Times New Roman" panose="02020603050405020304" pitchFamily="18" charset="0"/>
-                  <a:cs typeface="Times New Roman" panose="02020603050405020304" pitchFamily="18" charset="0"/>
-                </a:endParaRPr>
+                <a:r>
+                  <a:rPr lang="it-IT" sz="2200" dirty="0">
+                    <a:latin typeface="Times New Roman" panose="02020603050405020304" pitchFamily="18" charset="0"/>
+                    <a:cs typeface="Times New Roman" panose="02020603050405020304" pitchFamily="18" charset="0"/>
+                  </a:rPr>
+                  <a:t>.</a:t>
+                </a:r>
               </a:p>
             </p:txBody>
           </p:sp>

</xml_diff>